<commit_message>
Added placeholder for website screenshot
</commit_message>
<xml_diff>
--- a/Presentations/Biohack_Presentation.pptx
+++ b/Presentations/Biohack_Presentation.pptx
@@ -4562,6 +4562,41 @@
                 <a:cs typeface="Arial" panose="020B0604020202020204" pitchFamily="34" charset="0"/>
               </a:rPr>
               <a:t>Outputs csv data displaying filament growth and change in angle</a:t>
+            </a:r>
+          </a:p>
+        </p:txBody>
+      </p:sp>
+      <p:sp>
+        <p:nvSpPr>
+          <p:cNvPr id="3" name="TextBox 2">
+            <a:extLst>
+              <a:ext uri="{FF2B5EF4-FFF2-40B4-BE49-F238E27FC236}">
+                <a16:creationId xmlns:a16="http://schemas.microsoft.com/office/drawing/2014/main" id="{352E2DA5-8B5B-D3F0-59C9-CCBC0B93CB94}"/>
+              </a:ext>
+            </a:extLst>
+          </p:cNvPr>
+          <p:cNvSpPr txBox="1"/>
+          <p:nvPr/>
+        </p:nvSpPr>
+        <p:spPr>
+          <a:xfrm>
+            <a:off x="7046205" y="3244334"/>
+            <a:ext cx="4307595" cy="369332"/>
+          </a:xfrm>
+          <a:prstGeom prst="rect">
+            <a:avLst/>
+          </a:prstGeom>
+          <a:noFill/>
+        </p:spPr>
+        <p:txBody>
+          <a:bodyPr wrap="square" rtlCol="0">
+            <a:spAutoFit/>
+          </a:bodyPr>
+          <a:lstStyle/>
+          <a:p>
+            <a:r>
+              <a:rPr lang="en-GB" dirty="0"/>
+              <a:t>…Put screenshot of website</a:t>
             </a:r>
           </a:p>
         </p:txBody>

</xml_diff>

<commit_message>
Added something about other GFP-tagged proteins
</commit_message>
<xml_diff>
--- a/Presentations/Biohack_Presentation.pptx
+++ b/Presentations/Biohack_Presentation.pptx
@@ -4729,6 +4729,15 @@
                 <a:cs typeface="Arial" panose="020B0604020202020204" pitchFamily="34" charset="0"/>
               </a:rPr>
               <a:t>Applying to situations with multiple filaments</a:t>
+            </a:r>
+          </a:p>
+          <a:p>
+            <a:r>
+              <a:rPr lang="en-GB" sz="2600" dirty="0">
+                <a:latin typeface="Arial" panose="020B0604020202020204" pitchFamily="34" charset="0"/>
+                <a:cs typeface="Arial" panose="020B0604020202020204" pitchFamily="34" charset="0"/>
+              </a:rPr>
+              <a:t>Analysis of other GFP-tagged protein filament structures</a:t>
             </a:r>
           </a:p>
         </p:txBody>

</xml_diff>